<commit_message>
Update Selective-Observation-Final-v3  -  Repaired.pptx
</commit_message>
<xml_diff>
--- a/docs/Selective-Observation-Final-v3  -  Repaired.pptx
+++ b/docs/Selective-Observation-Final-v3  -  Repaired.pptx
@@ -522,20 +522,108 @@
           <a:lstStyle/>
           <a:p>
             <a:r>
+              <a:rPr sz="1200" dirty="0"/>
+              <a:t>[~45s] I want to be upfront about the limitations. First, 15 tasks is still small — no multi-seed sweep yet, and external validity remains </a:t>
+            </a:r>
+            <a:r>
               <a:rPr sz="1200"/>
-              <a:t>[~45s] I want to be upfront about the limitations. First, 15 tasks is still small — no multi-seed sweep yet, and external validity remains future work. The right next step is porting to OSWorld or WebArena. Second, we label at episode level; a step-level safety metric would be more granular. Third, the verbalized confidence signal is bimodal in practice — it either fires or it does not — which limits how much the threshold sweep can tune the gate. Despite this, the local suite serves a real diagnostic purpose: it shows exactly which task families the gate handles before we scale to an expensive external benchmark.</a:t>
-            </a:r>
-          </a:p>
-          <a:p>
-            <a:r>
-              <a:rPr sz="1100">
+              <a:t>future work. </a:t>
+            </a:r>
+            <a:r>
+              <a:rPr sz="1200" dirty="0"/>
+              <a:t>Second, we label at episode level; a step-level safety metric would be more granular. Third, the verbalized confidence signal is bimodal in practice — it either fires or it does not — which limits how much the threshold sweep can tune the gate. Despite this, the local suite serves a real diagnostic purpose: it shows exactly which task families the gate handles before we scale to an expensive external benchmark.</a:t>
+            </a:r>
+          </a:p>
+          <a:p>
+            <a:r>
+              <a:rPr sz="1100" dirty="0">
                 <a:solidFill>
                   <a:srgbClr val="94A3B8"/>
                 </a:solidFill>
               </a:rPr>
               <a:t>
-【中文参考翻译】
-我想坦诚地说明局限性。首先，15 个任务仍然很少——还没有进行多种子扫描，外部有效性仍然是未来的工作。正确的下一步是移植到 OSWorld 或 WebArena。其次，我们在 episode 层面进行标注；步骤级别的安全指标会更细粒度。第三，来自语言化模型输出的置信度信号在实践中是双峰分布的——它要么触发要么不触发——这限制了阈值扫描能够调整门控的程度。尽管如此，本地套件有其真正的诊断价值：在我们扩展到昂贵的外部基准测试之前，它准确地展示了门控能处理哪些任务系列。</a:t>
+【</a:t>
+            </a:r>
+            <a:r>
+              <a:rPr sz="1100" dirty="0" err="1">
+                <a:solidFill>
+                  <a:srgbClr val="94A3B8"/>
+                </a:solidFill>
+              </a:rPr>
+              <a:t>中文参考翻译</a:t>
+            </a:r>
+            <a:r>
+              <a:rPr sz="1100" dirty="0">
+                <a:solidFill>
+                  <a:srgbClr val="94A3B8"/>
+                </a:solidFill>
+              </a:rPr>
+              <a:t>】
+我想坦诚地说明局限性。首先，15 </a:t>
+            </a:r>
+            <a:r>
+              <a:rPr sz="1100" dirty="0" err="1">
+                <a:solidFill>
+                  <a:srgbClr val="94A3B8"/>
+                </a:solidFill>
+              </a:rPr>
+              <a:t>个任务仍然很少</a:t>
+            </a:r>
+            <a:r>
+              <a:rPr sz="1100" dirty="0">
+                <a:solidFill>
+                  <a:srgbClr val="94A3B8"/>
+                </a:solidFill>
+              </a:rPr>
+              <a:t>——</a:t>
+            </a:r>
+            <a:r>
+              <a:rPr sz="1100" dirty="0" err="1">
+                <a:solidFill>
+                  <a:srgbClr val="94A3B8"/>
+                </a:solidFill>
+              </a:rPr>
+              <a:t>还没有进行多种子扫描，外部有效性仍然是未来的工作。其次，我们在</a:t>
+            </a:r>
+            <a:r>
+              <a:rPr sz="1100" dirty="0">
+                <a:solidFill>
+                  <a:srgbClr val="94A3B8"/>
+                </a:solidFill>
+              </a:rPr>
+              <a:t> episode </a:t>
+            </a:r>
+            <a:r>
+              <a:rPr sz="1100" dirty="0" err="1">
+                <a:solidFill>
+                  <a:srgbClr val="94A3B8"/>
+                </a:solidFill>
+              </a:rPr>
+              <a:t>层面进行标注；步骤级别的安全指标会更细粒度。第三，来自语言化模型输出的置信度信号在实践中是双峰分布的</a:t>
+            </a:r>
+            <a:r>
+              <a:rPr sz="1100" dirty="0">
+                <a:solidFill>
+                  <a:srgbClr val="94A3B8"/>
+                </a:solidFill>
+              </a:rPr>
+              <a:t>——</a:t>
+            </a:r>
+            <a:r>
+              <a:rPr sz="1100" dirty="0" err="1">
+                <a:solidFill>
+                  <a:srgbClr val="94A3B8"/>
+                </a:solidFill>
+              </a:rPr>
+              <a:t>它要么触发要么不触发</a:t>
+            </a:r>
+            <a:r>
+              <a:rPr sz="1100" dirty="0">
+                <a:solidFill>
+                  <a:srgbClr val="94A3B8"/>
+                </a:solidFill>
+              </a:rPr>
+              <a:t>——这限制了阈值扫描能够调整门控的程度。尽管如此，本地套件有其真正的诊断价值：在我们扩展到昂贵的外部基准测试之前，它准确地展示了门控能处理哪些任务系列。</a:t>
             </a:r>
           </a:p>
         </p:txBody>
@@ -612,20 +700,210 @@
           <a:lstStyle/>
           <a:p>
             <a:r>
-              <a:rPr sz="1200"/>
-              <a:t>[~40s] Three things to take away. First, observation scheduling is learnable — a simple logistic gate trained on cheap features can decide when another DOM read is worth paying for. Second, learned beats handrule on the success-cost frontier — our gate at threshold 0.2 hits 100% success with 41% fewer calls than always, and 33% fewer than handrule, at zero unsafe rate. Third, the hard safety floor is essential — observation before irreversible actions is non-negotiable, and the gate only optimizes above that floor. Happy to take questions.</a:t>
-            </a:r>
-          </a:p>
-          <a:p>
-            <a:r>
-              <a:rPr sz="1100">
+              <a:rPr sz="1200" dirty="0"/>
+              <a:t>[~40s] Three things to take away. First, observation scheduling is learnable — a simple logistic gate trained on cheap features can decide when another DOM read is worth paying for. Second, learned beats </a:t>
+            </a:r>
+            <a:r>
+              <a:rPr sz="1200" dirty="0" err="1"/>
+              <a:t>handrule</a:t>
+            </a:r>
+            <a:r>
+              <a:rPr sz="1200" dirty="0"/>
+              <a:t> on the success-cost frontier — our gate at threshold 0.2 hits 100% success with 41% fewer calls than always, and 33% fewer than </a:t>
+            </a:r>
+            <a:r>
+              <a:rPr sz="1200" dirty="0" err="1"/>
+              <a:t>handrule</a:t>
+            </a:r>
+            <a:r>
+              <a:rPr sz="1200" dirty="0"/>
+              <a:t>, at zero unsafe rate. Third, the hard safety floor is essential — observation before irreversible actions is non-negotiable, and the gate only optimizes above that floor. </a:t>
+            </a:r>
+            <a:r>
+              <a:rPr sz="1100" dirty="0">
                 <a:solidFill>
                   <a:srgbClr val="94A3B8"/>
                 </a:solidFill>
               </a:rPr>
               <a:t>
-【中文参考翻译】
-三点总结。第一，观察调度是可学习的——一个在廉价特征上训练的简单逻辑门控可以决定什么时候另一次 DOM 读取值得付出代价。第二，学习方法在成功-成本前沿上优于手工规则——我们在阈值 0.2 的门控实现了 100% 成功率，比 always-observe 减少了 41% 的调用次数，比手工规则减少了 33%，零不安全率。第三，硬安全底线至关重要——不可逆操作前的观察是不可商量的，门控只在该底线以上进行优化。欢迎提问。</a:t>
+【</a:t>
+            </a:r>
+            <a:r>
+              <a:rPr sz="1100" dirty="0" err="1">
+                <a:solidFill>
+                  <a:srgbClr val="94A3B8"/>
+                </a:solidFill>
+              </a:rPr>
+              <a:t>中文参考翻译</a:t>
+            </a:r>
+            <a:r>
+              <a:rPr sz="1100" dirty="0">
+                <a:solidFill>
+                  <a:srgbClr val="94A3B8"/>
+                </a:solidFill>
+              </a:rPr>
+              <a:t>】
+</a:t>
+            </a:r>
+            <a:r>
+              <a:rPr sz="1100" dirty="0" err="1">
+                <a:solidFill>
+                  <a:srgbClr val="94A3B8"/>
+                </a:solidFill>
+              </a:rPr>
+              <a:t>三点总结。第一，观察调度是可学习的</a:t>
+            </a:r>
+            <a:r>
+              <a:rPr sz="1100" dirty="0">
+                <a:solidFill>
+                  <a:srgbClr val="94A3B8"/>
+                </a:solidFill>
+              </a:rPr>
+              <a:t>——</a:t>
+            </a:r>
+            <a:r>
+              <a:rPr sz="1100" dirty="0" err="1">
+                <a:solidFill>
+                  <a:srgbClr val="94A3B8"/>
+                </a:solidFill>
+              </a:rPr>
+              <a:t>一个在廉价特征上训练的简单逻辑门控可以决定什么时候另一次</a:t>
+            </a:r>
+            <a:r>
+              <a:rPr sz="1100" dirty="0">
+                <a:solidFill>
+                  <a:srgbClr val="94A3B8"/>
+                </a:solidFill>
+              </a:rPr>
+              <a:t> DOM </a:t>
+            </a:r>
+            <a:r>
+              <a:rPr sz="1100" dirty="0" err="1">
+                <a:solidFill>
+                  <a:srgbClr val="94A3B8"/>
+                </a:solidFill>
+              </a:rPr>
+              <a:t>读取值得付出代价。第二，学习方法在成功-成本前沿上优于手工规则</a:t>
+            </a:r>
+            <a:r>
+              <a:rPr sz="1100" dirty="0">
+                <a:solidFill>
+                  <a:srgbClr val="94A3B8"/>
+                </a:solidFill>
+              </a:rPr>
+              <a:t>——</a:t>
+            </a:r>
+            <a:r>
+              <a:rPr sz="1100" dirty="0" err="1">
+                <a:solidFill>
+                  <a:srgbClr val="94A3B8"/>
+                </a:solidFill>
+              </a:rPr>
+              <a:t>我们在阈值</a:t>
+            </a:r>
+            <a:r>
+              <a:rPr sz="1100" dirty="0">
+                <a:solidFill>
+                  <a:srgbClr val="94A3B8"/>
+                </a:solidFill>
+              </a:rPr>
+              <a:t> 0.2 </a:t>
+            </a:r>
+            <a:r>
+              <a:rPr sz="1100" dirty="0" err="1">
+                <a:solidFill>
+                  <a:srgbClr val="94A3B8"/>
+                </a:solidFill>
+              </a:rPr>
+              <a:t>的门控实现了</a:t>
+            </a:r>
+            <a:r>
+              <a:rPr sz="1100" dirty="0">
+                <a:solidFill>
+                  <a:srgbClr val="94A3B8"/>
+                </a:solidFill>
+              </a:rPr>
+              <a:t> 100% </a:t>
+            </a:r>
+            <a:r>
+              <a:rPr sz="1100" dirty="0" err="1">
+                <a:solidFill>
+                  <a:srgbClr val="94A3B8"/>
+                </a:solidFill>
+              </a:rPr>
+              <a:t>成功率，比</a:t>
+            </a:r>
+            <a:r>
+              <a:rPr sz="1100" dirty="0">
+                <a:solidFill>
+                  <a:srgbClr val="94A3B8"/>
+                </a:solidFill>
+              </a:rPr>
+              <a:t> always-observe </a:t>
+            </a:r>
+            <a:r>
+              <a:rPr sz="1100" dirty="0" err="1">
+                <a:solidFill>
+                  <a:srgbClr val="94A3B8"/>
+                </a:solidFill>
+              </a:rPr>
+              <a:t>减少了</a:t>
+            </a:r>
+            <a:r>
+              <a:rPr sz="1100" dirty="0">
+                <a:solidFill>
+                  <a:srgbClr val="94A3B8"/>
+                </a:solidFill>
+              </a:rPr>
+              <a:t> 41% </a:t>
+            </a:r>
+            <a:r>
+              <a:rPr sz="1100" dirty="0" err="1">
+                <a:solidFill>
+                  <a:srgbClr val="94A3B8"/>
+                </a:solidFill>
+              </a:rPr>
+              <a:t>的调用次数，比手工规则减少了</a:t>
+            </a:r>
+            <a:r>
+              <a:rPr sz="1100" dirty="0">
+                <a:solidFill>
+                  <a:srgbClr val="94A3B8"/>
+                </a:solidFill>
+              </a:rPr>
+              <a:t> 33%，</a:t>
+            </a:r>
+            <a:r>
+              <a:rPr sz="1100" dirty="0" err="1">
+                <a:solidFill>
+                  <a:srgbClr val="94A3B8"/>
+                </a:solidFill>
+              </a:rPr>
+              <a:t>零不安全率。第三，硬安全底线至关重要</a:t>
+            </a:r>
+            <a:r>
+              <a:rPr sz="1100" dirty="0">
+                <a:solidFill>
+                  <a:srgbClr val="94A3B8"/>
+                </a:solidFill>
+              </a:rPr>
+              <a:t>——</a:t>
+            </a:r>
+            <a:r>
+              <a:rPr sz="1100" dirty="0" err="1">
+                <a:solidFill>
+                  <a:srgbClr val="94A3B8"/>
+                </a:solidFill>
+              </a:rPr>
+              <a:t>不可逆操作前的观察是不可商量的，门控只在该底线以上进行优化</a:t>
+            </a:r>
+            <a:r>
+              <a:rPr sz="1100" dirty="0">
+                <a:solidFill>
+                  <a:srgbClr val="94A3B8"/>
+                </a:solidFill>
+              </a:rPr>
+              <a:t>。</a:t>
             </a:r>
           </a:p>
         </p:txBody>
@@ -6089,6 +6367,79 @@
           </a:p>
         </p:txBody>
       </p:sp>
+      <p:sp>
+        <p:nvSpPr>
+          <p:cNvPr id="37" name="Closing Elevation Band">
+            <a:extLst>
+              <a:ext uri="{FF2B5EF4-FFF2-40B4-BE49-F238E27FC236}">
+                <a16:creationId xmlns:a16="http://schemas.microsoft.com/office/drawing/2014/main" id="{3B594375-7A04-7E7A-9E77-5C76316C2003}"/>
+              </a:ext>
+            </a:extLst>
+          </p:cNvPr>
+          <p:cNvSpPr/>
+          <p:nvPr/>
+        </p:nvSpPr>
+        <p:spPr>
+          <a:xfrm>
+            <a:off x="666750" y="5200650"/>
+            <a:ext cx="10344150" cy="880000"/>
+          </a:xfrm>
+          <a:prstGeom prst="roundRect">
+            <a:avLst>
+              <a:gd name="adj" fmla="val 6000"/>
+            </a:avLst>
+          </a:prstGeom>
+          <a:solidFill>
+            <a:srgbClr val="0F172A"/>
+          </a:solidFill>
+        </p:spPr>
+        <p:txBody>
+          <a:bodyPr wrap="square" lIns="182880" tIns="73152" rIns="182880" bIns="73152" anchor="ctr"/>
+          <a:lstStyle/>
+          <a:p>
+            <a:pPr>
+              <a:spcAft>
+                <a:spcPts val="400"/>
+              </a:spcAft>
+            </a:pPr>
+            <a:r>
+              <a:rPr lang="en-US" sz="1000" b="1" spc="40" dirty="0">
+                <a:solidFill>
+                  <a:srgbClr val="B7C7D9"/>
+                </a:solidFill>
+                <a:latin typeface="Nunito Sans"/>
+              </a:rPr>
+              <a:t>Real web apps constantly act on state that may already be stale</a:t>
+            </a:r>
+            <a:r>
+              <a:rPr lang="en-US" altLang="zh-CN" sz="1000" b="1" spc="40" dirty="0">
+                <a:solidFill>
+                  <a:srgbClr val="B7C7D9"/>
+                </a:solidFill>
+                <a:latin typeface="Nunito Sans"/>
+              </a:rPr>
+              <a:t> — async content loading, background-resolved form fields, live-updating prices</a:t>
+            </a:r>
+            <a:endParaRPr lang="en-US" sz="1000" b="1" spc="40" dirty="0">
+              <a:solidFill>
+                <a:srgbClr val="B7C7D9"/>
+              </a:solidFill>
+              <a:latin typeface="Nunito Sans"/>
+            </a:endParaRPr>
+          </a:p>
+          <a:p>
+            <a:r>
+              <a:rPr lang="en-US" sz="1300" b="1" dirty="0">
+                <a:solidFill>
+                  <a:srgbClr val="FFFFFF"/>
+                </a:solidFill>
+                <a:latin typeface="Nunito Sans ExtraBold"/>
+              </a:rPr>
+              <a:t>So the contribution of this work is better understood as proposing and formalizing a previously unexplored research framework, rather than providing a production-ready solution for direct integration.</a:t>
+            </a:r>
+          </a:p>
+        </p:txBody>
+      </p:sp>
     </p:spTree>
     <p:extLst>
       <p:ext uri="{BB962C8B-B14F-4D97-AF65-F5344CB8AC3E}">

</xml_diff>